<commit_message>
Paper/slides: drop self-citation of the thesis (this paper is the thesis); describe CE-SE setup and comb in-paper
Co-Authored-By: Claude Opus 5.5 (1M context) <noreply@anthropic.com>
</commit_message>
<xml_diff>
--- a/results/progress_slides_2026-10b.pptx
+++ b/results/progress_slides_2026-10b.pptx
@@ -1253,7 +1253,7 @@
               <a:t>【台本】（約40秒）
 方法です。喉マイクの音を2つの処理に通します。
 上は前回の生成モデルで、ランダムな出発点を変えて4回生成し、振幅を平均します。これで生成のばらつきが打ち消されます。
-下は卒論で作った、Whisper が正しく書き起こせるように学習した音声強調です。
+下は、Whisper が正しく書き起こせるように学習した音声強調です。
 この2つの出力の振幅を半々で平均し、位相は生成モデルのものを使います。混ぜる割合は開発データで Whisper-small だけを見て選びましたが、0.25 から 0.75 でほとんど変わりません。
 【補足】振幅は STFT（512点、ずらし128点）。帯域ごとに割合を変えても差は1%前後。</a:t>
             </a:r>
@@ -1436,7 +1436,7 @@
             <a:r>
               <a:rPr lang="en-US" dirty="0"/>
               <a:t>【台本】（約35秒）
-既存の方法とも同じ条件で比べました。卒論の Whisper 用音声強調、自己教師あり表現を損失に使う Sato らの方法、生成モデル単体のどれと比べても、混ぜたものが6つすべてで一番良い結果です。
+既存の方法とも同じ条件で比べました。Whisper 用音声強調、自己教師あり表現を損失に使う Sato らの方法、生成モデル単体のどれと比べても、混ぜたものが6つすべてで一番良い結果です。
 また、Whisper の損失で mel を直接直す Dissen らの方法も試しましたが、喉マイクでは欠けた高域を補えず、元の音声強調と同じ程度でした。
 【補足】Dissen ら型: U-Net 約700万パラメータ、mel→mel、Whisper-small の CE＋気導 mel の L1。80本 mel の Whisper でしか使えない。</a:t>
             </a:r>
@@ -1803,7 +1803,7 @@
               <a:rPr lang="en-US" dirty="0"/>
               <a:t>【台本】（約35秒）
 今後は、提案手法になる形を3つの方向で小さく試します。
-1つ目は軽くすることで、混ぜた出力を教師にして、軽い音声強調1つに移します。2つ目はフランス語の喉マイクのデータで、同じ結論になるかを確かめます。3つ目は他分野の発想です。画像の敵対的サンプルの研究では、1つのモデルの中をランダムに揺らしながら作った摂動ほど、別のモデルにも効くことが知られています。これを Whisper 用音声強調の学習に持ち込み、Whisper-small だけで学習しても、base など学習に使わない Whisper にも効くようにします。卒論の Whisper 用音声強調は base にはほとんど効かなかったので、ここが直接の課題です。
+1つ目は軽くすることで、混ぜた出力を教師にして、軽い音声強調1つに移します。2つ目はフランス語の喉マイクのデータで、同じ結論になるかを確かめます。3つ目は他分野の発想です。画像の敵対的サンプルの研究では、1つのモデルの中をランダムに揺らしながら作った摂動ほど、別のモデルにも効くことが知られています。これを Whisper 用音声強調の学習に持ち込み、Whisper-small だけで学習しても、base など学習に使わない Whisper にも効くようにします。Whisper 用音声強調は単体では base にほとんど効かなかったので、ここが直接の課題です。
 【補足】Ghost Networks（Li et al., AAAI 2020）、Input Diversity（Xie et al., CVPR 2019）。音声強調の学習に使った例は調べた範囲では見つからない。ほかの候補（生成サンプルの区間ごとの選択、時間周波数ごとの不確かさで重みづけ、ケプストラム領域での融合）は別資料。
 以上です。</a:t>
             </a:r>
@@ -3454,7 +3454,7 @@
                 <a:ea typeface="Yu Gothic" pitchFamily="34" charset="-122"/>
                 <a:cs typeface="Yu Gothic" pitchFamily="34" charset="-120"/>
               </a:rPr>
-              <a:t>Whisper 用の音声強調（卒論）</a:t>
+              <a:t>Whisper 用の音声強調</a:t>
             </a:r>
             <a:endParaRPr lang="en-US" sz="1700" dirty="0"/>
           </a:p>

</xml_diff>